<commit_message>
Add pre-lab, glossary, model exhibit and speaker notes
</commit_message>
<xml_diff>
--- a/Lab 01/Lab 01 Deep Dive - find, Pipelines and Worked Examples.pptx
+++ b/Lab 01/Lab 01 Deep Dive - find, Pipelines and Worked Examples.pptx
@@ -522,10 +522,8 @@
           <a:lstStyle/>
           <a:p>
             <a:r>
-              <a:rPr lang="en-US" dirty="0"/>
-              <a:t/>
-            </a:r>
-            <a:endParaRPr lang="en-US" dirty="0"/>
+              <a:t>Companion session - assumes students saw the main deck. Goal: turn knowledge into reflexes - find operators, pipelines, then worked examples up to Challenge A only. Budget about 120 minutes including the worked drills.</a:t>
+            </a:r>
           </a:p>
         </p:txBody>
       </p:sp>
@@ -610,10 +608,8 @@
           <a:lstStyle/>
           <a:p>
             <a:r>
-              <a:rPr lang="en-US" dirty="0"/>
-              <a:t/>
-            </a:r>
-            <a:endParaRPr lang="en-US" dirty="0"/>
+              <a:t>Reference pack 2 of 8. Star option: cat -A - reveal the evidence_B trick here (one trailing space changes the hash). strings -e l previews Windows artifacts in Lab 02.</a:t>
+            </a:r>
           </a:p>
         </p:txBody>
       </p:sp>
@@ -698,10 +694,8 @@
           <a:lstStyle/>
           <a:p>
             <a:r>
-              <a:rPr lang="en-US" dirty="0"/>
-              <a:t/>
-            </a:r>
-            <a:endParaRPr lang="en-US" dirty="0"/>
+              <a:t>Reference pack 3 of 8. Run the -oE IP extraction live; it feeds Challenge C directly. The -A/-B/-C context flags are how you see the events AROUND an incident, not just the incident line.</a:t>
+            </a:r>
           </a:p>
         </p:txBody>
       </p:sp>
@@ -786,10 +780,8 @@
           <a:lstStyle/>
           <a:p>
             <a:r>
-              <a:rPr lang="en-US" dirty="0"/>
-              <a:t/>
-            </a:r>
-            <a:endParaRPr lang="en-US" dirty="0"/>
+              <a:t>Reference pack 4 of 8. Highlight -inum and -perm -4000 (setuid inventory). Time filters already got their own slides earlier.</a:t>
+            </a:r>
           </a:p>
         </p:txBody>
       </p:sp>
@@ -874,10 +866,8 @@
           <a:lstStyle/>
           <a:p>
             <a:r>
-              <a:rPr lang="en-US" dirty="0"/>
-              <a:t/>
-            </a:r>
-            <a:endParaRPr lang="en-US" dirty="0"/>
+              <a:t>Run the verify loop live: write hashes.txt, tamper with a copy, sha1sum -c prints FAILED. This loop IS the evidence discipline graded in the working paper.</a:t>
+            </a:r>
           </a:p>
         </p:txBody>
       </p:sp>
@@ -962,10 +952,8 @@
           <a:lstStyle/>
           <a:p>
             <a:r>
-              <a:rPr lang="en-US" dirty="0"/>
-              <a:t/>
-            </a:r>
-            <a:endParaRPr lang="en-US" dirty="0"/>
+              <a:t>Reference pack 6 of 8. xxd -s 12 reading IHDR is the exact move Challenge B needs - but do NOT say that out loud; let students make the connection themselves during the challenge.</a:t>
+            </a:r>
           </a:p>
         </p:txBody>
       </p:sp>
@@ -1050,10 +1038,8 @@
           <a:lstStyle/>
           <a:p>
             <a:r>
-              <a:rPr lang="en-US" dirty="0"/>
-              <a:t/>
-            </a:r>
-            <a:endParaRPr lang="en-US" dirty="0"/>
+              <a:t>Reference pack 7 of 8. netstat -p needs root; the -n flag avoids DNS lookups (faster, and does not touch a resolver during live response). ss is the modern replacement.</a:t>
+            </a:r>
           </a:p>
         </p:txBody>
       </p:sp>
@@ -1138,10 +1124,8 @@
           <a:lstStyle/>
           <a:p>
             <a:r>
-              <a:rPr lang="en-US" dirty="0"/>
-              <a:t/>
-            </a:r>
-            <a:endParaRPr lang="en-US" dirty="0"/>
+              <a:t>Reference pack 8 of 8. Key fact to repeat: uniq -c requires sorted input - the classic silent pipeline bug.</a:t>
+            </a:r>
           </a:p>
         </p:txBody>
       </p:sp>
@@ -1226,10 +1210,8 @@
           <a:lstStyle/>
           <a:p>
             <a:r>
-              <a:rPr lang="en-US" dirty="0"/>
-              <a:t/>
-            </a:r>
-            <a:endParaRPr lang="en-US" dirty="0"/>
+              <a:t>The awk slide. Repeat the rule of thumb: a pattern IN a line means grep; a COLUMN's value means awk. Show the grep anchor traps once - students will meet them again in Challenge C.</a:t>
+            </a:r>
           </a:p>
         </p:txBody>
       </p:sp>
@@ -1314,10 +1296,8 @@
           <a:lstStyle/>
           <a:p>
             <a:r>
-              <a:rPr lang="en-US" dirty="0"/>
-              <a:t/>
-            </a:r>
-            <a:endParaRPr lang="en-US" dirty="0"/>
+              <a:t>Worked drills start - pick up the pace, they have seen the commands already. Where possible, run the commands live instead of reading the terminal block.</a:t>
+            </a:r>
           </a:p>
         </p:txBody>
       </p:sp>
@@ -1402,10 +1382,8 @@
           <a:lstStyle/>
           <a:p>
             <a:r>
-              <a:rPr lang="en-US" dirty="0"/>
-              <a:t/>
-            </a:r>
-            <a:endParaRPr lang="en-US" dirty="0"/>
+              <a:t>server.log case: let students predict each answer before you reveal it. This is the guided rehearsal for Challenge C - same moves, bigger file.</a:t>
+            </a:r>
           </a:p>
         </p:txBody>
       </p:sp>
@@ -1490,10 +1468,8 @@
           <a:lstStyle/>
           <a:p>
             <a:r>
-              <a:rPr lang="en-US" dirty="0"/>
-              <a:t/>
-            </a:r>
-            <a:endParaRPr lang="en-US" dirty="0"/>
+              <a:t>Five parts. Note that part 3 is a reference pack: students should keep it (screenshot or print); nobody memorizes option tables.</a:t>
+            </a:r>
           </a:p>
         </p:txBody>
       </p:sp>
@@ -1578,10 +1554,8 @@
           <a:lstStyle/>
           <a:p>
             <a:r>
-              <a:rPr lang="en-US" dirty="0"/>
-              <a:t/>
-            </a:r>
-            <a:endParaRPr lang="en-US" dirty="0"/>
+              <a:t>Hash pair plus the lying header. The evidence_B reveal lands here. Stop before saying what challenge_extra really is - that discovery belongs to Challenge B.</a:t>
+            </a:r>
           </a:p>
         </p:txBody>
       </p:sp>
@@ -1666,10 +1640,8 @@
           <a:lstStyle/>
           <a:p>
             <a:r>
-              <a:rPr lang="en-US" dirty="0"/>
-              <a:t/>
-            </a:r>
-            <a:endParaRPr lang="en-US" dirty="0"/>
+              <a:t>Challenge A fully worked - this is the flag-reveal moment of the course so far. Afterwards remind them: B is the same skill with a twist, C is a different skill entirely; both are solo from here.</a:t>
+            </a:r>
           </a:p>
         </p:txBody>
       </p:sp>
@@ -1754,10 +1726,8 @@
           <a:lstStyle/>
           <a:p>
             <a:r>
-              <a:rPr lang="en-US" dirty="0"/>
-              <a:t/>
-            </a:r>
-            <a:endParaRPr lang="en-US" dirty="0"/>
+              <a:t>Assign the deadline and submission format now. Remind: staged hints in section 4 of the working paper, evidence numbering, hashes before and after. Give no hints on B or C from this point.</a:t>
+            </a:r>
           </a:p>
         </p:txBody>
       </p:sp>
@@ -1842,10 +1812,8 @@
           <a:lstStyle/>
           <a:p>
             <a:r>
-              <a:rPr lang="en-US" dirty="0"/>
-              <a:t/>
-            </a:r>
-            <a:endParaRPr lang="en-US" dirty="0"/>
+              <a:t>The OR slide. Quiz first: what does the ungrouped -print version actually print? Let them guess wrong, then show the fix with the escaped parentheses. Mention this gotcha silently deletes the wrong files when -delete is involved.</a:t>
+            </a:r>
           </a:p>
         </p:txBody>
       </p:sp>
@@ -1930,10 +1898,8 @@
           <a:lstStyle/>
           <a:p>
             <a:r>
-              <a:rPr lang="en-US" dirty="0"/>
-              <a:t/>
-            </a:r>
-            <a:endParaRPr lang="en-US" dirty="0"/>
+              <a:t>Poll: what does -mtime 1 mean? Most answer 'yesterday' - the 24-to-48-hours truth surprises them. -mmin is the precision tool; note 15 days equals -mmin -21600.</a:t>
+            </a:r>
           </a:p>
         </p:txBody>
       </p:sp>
@@ -2018,10 +1984,8 @@
           <a:lstStyle/>
           <a:p>
             <a:r>
-              <a:rPr lang="en-US" dirty="0"/>
-              <a:t/>
-            </a:r>
-            <a:endParaRPr lang="en-US" dirty="0"/>
+              <a:t>-newermt is how you bracket an incident window in time. Tie-in for later: filesystem timestamps can be forged (timestomping); authoritative timelines come from the MFT in Lab 06.</a:t>
+            </a:r>
           </a:p>
         </p:txBody>
       </p:sp>
@@ -2106,10 +2070,8 @@
           <a:lstStyle/>
           <a:p>
             <a:r>
-              <a:rPr lang="en-US" dirty="0"/>
-              <a:t/>
-            </a:r>
-            <a:endParaRPr lang="en-US" dirty="0"/>
+              <a:t>The pipe mental model: stdout of the left command becomes stdin of the right. Walk the three boxes slowly. The cat-grep-wc example intentionally duplicates grep -c to show the pipe makes every tool reusable.</a:t>
+            </a:r>
           </a:p>
         </p:txBody>
       </p:sp>
@@ -2194,10 +2156,8 @@
           <a:lstStyle/>
           <a:p>
             <a:r>
-              <a:rPr lang="en-US" dirty="0"/>
-              <a:t/>
-            </a:r>
-            <a:endParaRPr lang="en-US" dirty="0"/>
+              <a:t>These four pipelines cover roughly ninety percent of the whole course. The IP-ranking one returns verbatim in Challenge C and again in Lab 04.</a:t>
+            </a:r>
           </a:p>
         </p:txBody>
       </p:sp>
@@ -2282,10 +2242,8 @@
           <a:lstStyle/>
           <a:p>
             <a:r>
-              <a:rPr lang="en-US" dirty="0"/>
-              <a:t/>
-            </a:r>
-            <a:endParaRPr lang="en-US" dirty="0"/>
+              <a:t>Anatomy slide. Ask what breaks if sort is removed before uniq -c (uniq only counts adjacent duplicates). Walk one real line through all five stages if time allows.</a:t>
+            </a:r>
           </a:p>
         </p:txBody>
       </p:sp>
@@ -2370,10 +2328,8 @@
           <a:lstStyle/>
           <a:p>
             <a:r>
-              <a:rPr lang="en-US" dirty="0"/>
-              <a:t/>
-            </a:r>
-            <a:endParaRPr lang="en-US" dirty="0"/>
+              <a:t>Reference pack 1 of 8. Do not read rows; highlight ls --full-time, ls -i (inode teaser for Lab 06), and file -z.</a:t>
+            </a:r>
           </a:p>
         </p:txBody>
       </p:sp>

</xml_diff>